<commit_message>
Pipeline completo ML+MLP para prediccion de cancer — UAX 2025/26
Co-Authored-By: Claude Sonnet 4.6 <noreply@anthropic.com>
</commit_message>
<xml_diff>
--- a/Entregable_5_diapositivas.pptx
+++ b/Entregable_5_diapositivas.pptx
@@ -1959,7 +1959,7 @@
                 <a:ea typeface="Georgia" pitchFamily="34" charset="-122"/>
                 <a:cs typeface="Georgia" pitchFamily="34" charset="-120"/>
               </a:rPr>
-              <a:t>0,5719</a:t>
+              <a:t>0,5748</a:t>
             </a:r>
             <a:endParaRPr lang="en-US" sz="2800" dirty="0"/>
           </a:p>
@@ -7571,7 +7571,7 @@
                 <a:ea typeface="Georgia" pitchFamily="34" charset="-122"/>
                 <a:cs typeface="Georgia" pitchFamily="34" charset="-120"/>
               </a:rPr>
-              <a:t>46.801</a:t>
+              <a:t>45.961</a:t>
             </a:r>
             <a:endParaRPr lang="en-US" sz="2800" dirty="0"/>
           </a:p>
@@ -7708,7 +7708,7 @@
                 <a:ea typeface="Georgia" pitchFamily="34" charset="-122"/>
                 <a:cs typeface="Georgia" pitchFamily="34" charset="-120"/>
               </a:rPr>
-              <a:t>31</a:t>
+              <a:t>17</a:t>
             </a:r>
             <a:endParaRPr lang="en-US" sz="2800" dirty="0"/>
           </a:p>
@@ -7845,7 +7845,7 @@
                 <a:ea typeface="Georgia" pitchFamily="34" charset="-122"/>
                 <a:cs typeface="Georgia" pitchFamily="34" charset="-120"/>
               </a:rPr>
-              <a:t>42 s</a:t>
+              <a:t>21 s</a:t>
             </a:r>
             <a:endParaRPr lang="en-US" sz="2800" dirty="0"/>
           </a:p>
@@ -8507,7 +8507,7 @@
                           <a:ea typeface="Calibri" pitchFamily="34" charset="-122"/>
                           <a:cs typeface="Calibri" pitchFamily="34" charset="-120"/>
                         </a:rPr>
-                        <a:t>0,5413</a:t>
+                        <a:t>0,5521</a:t>
                       </a:r>
                       <a:endParaRPr lang="en-US" sz="1000" dirty="0">
                         <a:latin typeface="Calibri" charset="0"/>
@@ -8572,7 +8572,7 @@
                           <a:ea typeface="Calibri" pitchFamily="34" charset="-122"/>
                           <a:cs typeface="Calibri" pitchFamily="34" charset="-120"/>
                         </a:rPr>
-                        <a:t>0,8337</a:t>
+                        <a:t>0,8418</a:t>
                       </a:r>
                       <a:endParaRPr lang="en-US" sz="1000" dirty="0">
                         <a:latin typeface="Calibri" charset="0"/>
@@ -8637,7 +8637,7 @@
                           <a:ea typeface="Calibri" pitchFamily="34" charset="-122"/>
                           <a:cs typeface="Calibri" pitchFamily="34" charset="-120"/>
                         </a:rPr>
-                        <a:t>0,4182</a:t>
+                        <a:t>0,4282</a:t>
                       </a:r>
                       <a:endParaRPr lang="en-US" sz="1000" dirty="0">
                         <a:latin typeface="Calibri" charset="0"/>
@@ -8702,7 +8702,7 @@
                           <a:ea typeface="Calibri" pitchFamily="34" charset="-122"/>
                           <a:cs typeface="Calibri" pitchFamily="34" charset="-120"/>
                         </a:rPr>
-                        <a:t>0,7672</a:t>
+                        <a:t>0,7766</a:t>
                       </a:r>
                       <a:endParaRPr lang="en-US" sz="1000" dirty="0">
                         <a:latin typeface="Calibri" charset="0"/>
@@ -8763,13 +8763,13 @@
                       <a:r>
                         <a:rPr lang="en-US" sz="1000" b="1" dirty="0">
                           <a:solidFill>
-                            <a:srgbClr val="1A1A2E"/>
+                            <a:srgbClr val="FFFFFF"/>
                           </a:solidFill>
                           <a:latin typeface="Calibri" pitchFamily="34" charset="0"/>
                           <a:ea typeface="Calibri" pitchFamily="34" charset="-122"/>
                           <a:cs typeface="Calibri" pitchFamily="34" charset="-120"/>
                         </a:rPr>
-                        <a:t>MLP umbral 0,64 (optimo)</a:t>
+                        <a:t>MLP umbral 0,63 (GANADOR)</a:t>
                       </a:r>
                       <a:endParaRPr lang="en-US" sz="1000" dirty="0">
                         <a:latin typeface="Calibri" charset="0"/>
@@ -8816,7 +8816,7 @@
                       <a:tailEnd type="none" w="med" len="med"/>
                     </a:lnB>
                     <a:solidFill>
-                      <a:srgbClr val="CADCFC"/>
+                      <a:srgbClr val="6A0DAD"/>
                     </a:solidFill>
                   </a:tcPr>
                 </a:tc>
@@ -8831,13 +8831,13 @@
                       <a:r>
                         <a:rPr lang="en-US" sz="1000" b="1" dirty="0">
                           <a:solidFill>
-                            <a:srgbClr val="6A0DAD"/>
+                            <a:srgbClr val="FFFFFF"/>
                           </a:solidFill>
                           <a:latin typeface="Calibri" pitchFamily="34" charset="0"/>
                           <a:ea typeface="Calibri" pitchFamily="34" charset="-122"/>
                           <a:cs typeface="Calibri" pitchFamily="34" charset="-120"/>
                         </a:rPr>
-                        <a:t>0,5615</a:t>
+                        <a:t>0,5748</a:t>
                       </a:r>
                       <a:endParaRPr lang="en-US" sz="1000" dirty="0">
                         <a:latin typeface="Calibri" charset="0"/>
@@ -8884,7 +8884,7 @@
                       <a:tailEnd type="none" w="med" len="med"/>
                     </a:lnB>
                     <a:solidFill>
-                      <a:srgbClr val="CADCFC"/>
+                      <a:srgbClr val="6A0DAD"/>
                     </a:solidFill>
                   </a:tcPr>
                 </a:tc>
@@ -8899,13 +8899,13 @@
                       <a:r>
                         <a:rPr lang="en-US" sz="1000" b="1" dirty="0">
                           <a:solidFill>
-                            <a:srgbClr val="1A1A2E"/>
+                            <a:srgbClr val="FFFFFF"/>
                           </a:solidFill>
                           <a:latin typeface="Calibri" pitchFamily="34" charset="0"/>
                           <a:ea typeface="Calibri" pitchFamily="34" charset="-122"/>
                           <a:cs typeface="Calibri" pitchFamily="34" charset="-120"/>
                         </a:rPr>
-                        <a:t>0,8337</a:t>
+                        <a:t>0,8418</a:t>
                       </a:r>
                       <a:endParaRPr lang="en-US" sz="1000" dirty="0">
                         <a:latin typeface="Calibri" charset="0"/>
@@ -8952,7 +8952,7 @@
                       <a:tailEnd type="none" w="med" len="med"/>
                     </a:lnB>
                     <a:solidFill>
-                      <a:srgbClr val="CADCFC"/>
+                      <a:srgbClr val="6A0DAD"/>
                     </a:solidFill>
                   </a:tcPr>
                 </a:tc>
@@ -8967,13 +8967,13 @@
                       <a:r>
                         <a:rPr lang="en-US" sz="1000" b="1" dirty="0">
                           <a:solidFill>
-                            <a:srgbClr val="1A1A2E"/>
+                            <a:srgbClr val="FFFFFF"/>
                           </a:solidFill>
                           <a:latin typeface="Calibri" pitchFamily="34" charset="0"/>
                           <a:ea typeface="Calibri" pitchFamily="34" charset="-122"/>
                           <a:cs typeface="Calibri" pitchFamily="34" charset="-120"/>
                         </a:rPr>
-                        <a:t>0,5138</a:t>
+                        <a:t>0,5305</a:t>
                       </a:r>
                       <a:endParaRPr lang="en-US" sz="1000" dirty="0">
                         <a:latin typeface="Calibri" charset="0"/>
@@ -9020,7 +9020,7 @@
                       <a:tailEnd type="none" w="med" len="med"/>
                     </a:lnB>
                     <a:solidFill>
-                      <a:srgbClr val="CADCFC"/>
+                      <a:srgbClr val="6A0DAD"/>
                     </a:solidFill>
                   </a:tcPr>
                 </a:tc>
@@ -9035,13 +9035,13 @@
                       <a:r>
                         <a:rPr lang="en-US" sz="1000" b="1" dirty="0">
                           <a:solidFill>
-                            <a:srgbClr val="1A1A2E"/>
+                            <a:srgbClr val="FFFFFF"/>
                           </a:solidFill>
                           <a:latin typeface="Calibri" pitchFamily="34" charset="0"/>
                           <a:ea typeface="Calibri" pitchFamily="34" charset="-122"/>
                           <a:cs typeface="Calibri" pitchFamily="34" charset="-120"/>
                         </a:rPr>
-                        <a:t>0,6190</a:t>
+                        <a:t>0,6273</a:t>
                       </a:r>
                       <a:endParaRPr lang="en-US" sz="1000" dirty="0">
                         <a:latin typeface="Calibri" charset="0"/>
@@ -9088,7 +9088,7 @@
                       <a:tailEnd type="none" w="med" len="med"/>
                     </a:lnB>
                     <a:solidFill>
-                      <a:srgbClr val="CADCFC"/>
+                      <a:srgbClr val="6A0DAD"/>
                     </a:solidFill>
                   </a:tcPr>
                 </a:tc>
@@ -9111,7 +9111,7 @@
                           <a:ea typeface="Calibri" pitchFamily="34" charset="-122"/>
                           <a:cs typeface="Calibri" pitchFamily="34" charset="-120"/>
                         </a:rPr>
-                        <a:t>RandomForest (GANADOR)</a:t>
+                        <a:t>RandomForest (mejor ML)</a:t>
                       </a:r>
                       <a:endParaRPr lang="en-US" sz="1000" dirty="0">
                         <a:latin typeface="Calibri" charset="0"/>
@@ -9497,7 +9497,7 @@
                 <a:ea typeface="Calibri" pitchFamily="34" charset="-122"/>
                 <a:cs typeface="Calibri" pitchFamily="34" charset="-120"/>
               </a:rPr>
-              <a:t>Hallazgo metodologico
+              <a:t>Hallazgo: la red neuronal gana
 </a:t>
             </a:r>
             <a:pPr algn="ctr" indent="0" marL="0">
@@ -9512,7 +9512,7 @@
                 <a:ea typeface="Calibri" pitchFamily="34" charset="-122"/>
                 <a:cs typeface="Calibri" pitchFamily="34" charset="-120"/>
               </a:rPr>
-              <a:t>El feature engineering (n_mutaciones, n_comorbilidades) </a:t>
+              <a:t>Con threshold tuning sobre validacion (umbral=0,63), </a:t>
             </a:r>
             <a:pPr algn="ctr" indent="0" marL="0">
               <a:buNone/>
@@ -9526,7 +9526,7 @@
                 <a:ea typeface="Calibri" pitchFamily="34" charset="-122"/>
                 <a:cs typeface="Calibri" pitchFamily="34" charset="-120"/>
               </a:rPr>
-              <a:t>ayuda a los arboles pero no al MLP. RandomForest gana.</a:t>
+              <a:t>el MLP supera a los 4 modelos ML clasicos en F1.</a:t>
             </a:r>
             <a:endParaRPr lang="en-US" sz="1200" dirty="0"/>
           </a:p>
@@ -10461,7 +10461,7 @@
                       <a:tailEnd type="none" w="med" len="med"/>
                     </a:lnB>
                     <a:solidFill>
-                      <a:srgbClr val="E63946"/>
+                      <a:srgbClr val="6A0DAD"/>
                     </a:solidFill>
                   </a:tcPr>
                 </a:tc>
@@ -10482,7 +10482,7 @@
                           <a:ea typeface="Calibri" pitchFamily="34" charset="-122"/>
                           <a:cs typeface="Calibri" pitchFamily="34" charset="-120"/>
                         </a:rPr>
-                        <a:t>RandomForest (+ feat eng)</a:t>
+                        <a:t>MLP umbral 0,63 (PyTorch)</a:t>
                       </a:r>
                       <a:endParaRPr lang="en-US" sz="1100" dirty="0">
                         <a:latin typeface="Calibri" charset="0"/>
@@ -10529,7 +10529,7 @@
                       <a:tailEnd type="none" w="med" len="med"/>
                     </a:lnB>
                     <a:solidFill>
-                      <a:srgbClr val="E63946"/>
+                      <a:srgbClr val="6A0DAD"/>
                     </a:solidFill>
                   </a:tcPr>
                 </a:tc>
@@ -10550,7 +10550,7 @@
                           <a:ea typeface="Calibri" pitchFamily="34" charset="-122"/>
                           <a:cs typeface="Calibri" pitchFamily="34" charset="-120"/>
                         </a:rPr>
-                        <a:t>0,5719</a:t>
+                        <a:t>0,5748</a:t>
                       </a:r>
                       <a:endParaRPr lang="en-US" sz="1100" dirty="0">
                         <a:latin typeface="Calibri" charset="0"/>
@@ -10597,7 +10597,7 @@
                       <a:tailEnd type="none" w="med" len="med"/>
                     </a:lnB>
                     <a:solidFill>
-                      <a:srgbClr val="E63946"/>
+                      <a:srgbClr val="6A0DAD"/>
                     </a:solidFill>
                   </a:tcPr>
                 </a:tc>
@@ -10618,7 +10618,7 @@
                           <a:ea typeface="Calibri" pitchFamily="34" charset="-122"/>
                           <a:cs typeface="Calibri" pitchFamily="34" charset="-120"/>
                         </a:rPr>
-                        <a:t>0,8367</a:t>
+                        <a:t>0,8418</a:t>
                       </a:r>
                       <a:endParaRPr lang="en-US" sz="1100" dirty="0">
                         <a:latin typeface="Calibri" charset="0"/>
@@ -10665,7 +10665,7 @@
                       <a:tailEnd type="none" w="med" len="med"/>
                     </a:lnB>
                     <a:solidFill>
-                      <a:srgbClr val="E63946"/>
+                      <a:srgbClr val="6A0DAD"/>
                     </a:solidFill>
                   </a:tcPr>
                 </a:tc>
@@ -10686,7 +10686,7 @@
                           <a:ea typeface="Calibri" pitchFamily="34" charset="-122"/>
                           <a:cs typeface="Calibri" pitchFamily="34" charset="-120"/>
                         </a:rPr>
-                        <a:t>0,4990</a:t>
+                        <a:t>0,5305</a:t>
                       </a:r>
                       <a:endParaRPr lang="en-US" sz="1100" dirty="0">
                         <a:latin typeface="Calibri" charset="0"/>
@@ -10733,7 +10733,7 @@
                       <a:tailEnd type="none" w="med" len="med"/>
                     </a:lnB>
                     <a:solidFill>
-                      <a:srgbClr val="E63946"/>
+                      <a:srgbClr val="6A0DAD"/>
                     </a:solidFill>
                   </a:tcPr>
                 </a:tc>
@@ -10754,7 +10754,7 @@
                           <a:ea typeface="Calibri" pitchFamily="34" charset="-122"/>
                           <a:cs typeface="Calibri" pitchFamily="34" charset="-120"/>
                         </a:rPr>
-                        <a:t>0,6698</a:t>
+                        <a:t>0,6273</a:t>
                       </a:r>
                       <a:endParaRPr lang="en-US" sz="1100" dirty="0">
                         <a:latin typeface="Calibri" charset="0"/>
@@ -10801,7 +10801,7 @@
                       <a:tailEnd type="none" w="med" len="med"/>
                     </a:lnB>
                     <a:solidFill>
-                      <a:srgbClr val="E63946"/>
+                      <a:srgbClr val="6A0DAD"/>
                     </a:solidFill>
                   </a:tcPr>
                 </a:tc>
@@ -10886,13 +10886,13 @@
                       <a:r>
                         <a:rPr lang="en-US" sz="1100" b="1" dirty="0">
                           <a:solidFill>
-                            <a:srgbClr val="6A0DAD"/>
+                            <a:srgbClr val="E63946"/>
                           </a:solidFill>
                           <a:latin typeface="Calibri" pitchFamily="34" charset="0"/>
                           <a:ea typeface="Calibri" pitchFamily="34" charset="-122"/>
                           <a:cs typeface="Calibri" pitchFamily="34" charset="-120"/>
                         </a:rPr>
-                        <a:t>MLP (umbral 0,69)</a:t>
+                        <a:t>RandomForest (+ feat eng)</a:t>
                       </a:r>
                       <a:endParaRPr lang="en-US" sz="1100" dirty="0">
                         <a:latin typeface="Calibri" charset="0"/>
@@ -10960,7 +10960,7 @@
                           <a:ea typeface="Calibri" pitchFamily="34" charset="-122"/>
                           <a:cs typeface="Calibri" pitchFamily="34" charset="-120"/>
                         </a:rPr>
-                        <a:t>0,5615</a:t>
+                        <a:t>0,5719</a:t>
                       </a:r>
                       <a:endParaRPr lang="en-US" sz="1100" dirty="0">
                         <a:latin typeface="Calibri" charset="0"/>
@@ -11028,7 +11028,7 @@
                           <a:ea typeface="Calibri" pitchFamily="34" charset="-122"/>
                           <a:cs typeface="Calibri" pitchFamily="34" charset="-120"/>
                         </a:rPr>
-                        <a:t>0,8337</a:t>
+                        <a:t>0,8367</a:t>
                       </a:r>
                       <a:endParaRPr lang="en-US" sz="1100" dirty="0">
                         <a:latin typeface="Calibri" charset="0"/>
@@ -11096,7 +11096,7 @@
                           <a:ea typeface="Calibri" pitchFamily="34" charset="-122"/>
                           <a:cs typeface="Calibri" pitchFamily="34" charset="-120"/>
                         </a:rPr>
-                        <a:t>0,5138</a:t>
+                        <a:t>0,4990</a:t>
                       </a:r>
                       <a:endParaRPr lang="en-US" sz="1100" dirty="0">
                         <a:latin typeface="Calibri" charset="0"/>
@@ -11164,7 +11164,7 @@
                           <a:ea typeface="Calibri" pitchFamily="34" charset="-122"/>
                           <a:cs typeface="Calibri" pitchFamily="34" charset="-120"/>
                         </a:rPr>
-                        <a:t>0,6190</a:t>
+                        <a:t>0,6698</a:t>
                       </a:r>
                       <a:endParaRPr lang="en-US" sz="1100" dirty="0">
                         <a:latin typeface="Calibri" charset="0"/>
@@ -12782,11 +12782,11 @@
             <a:avLst/>
           </a:prstGeom>
           <a:solidFill>
-            <a:srgbClr val="E63946"/>
+            <a:srgbClr val="6A0DAD"/>
           </a:solidFill>
           <a:ln w="12700">
             <a:solidFill>
-              <a:srgbClr val="E63946"/>
+              <a:srgbClr val="6A0DAD"/>
             </a:solidFill>
             <a:prstDash val="solid"/>
           </a:ln>
@@ -12821,13 +12821,13 @@
             <a:r>
               <a:rPr lang="en-US" sz="2800" b="1" dirty="0">
                 <a:solidFill>
-                  <a:srgbClr val="E63946"/>
+                  <a:srgbClr val="6A0DAD"/>
                 </a:solidFill>
                 <a:latin typeface="Georgia" pitchFamily="34" charset="0"/>
                 <a:ea typeface="Georgia" pitchFamily="34" charset="-122"/>
                 <a:cs typeface="Georgia" pitchFamily="34" charset="-120"/>
               </a:rPr>
-              <a:t>0,5719</a:t>
+              <a:t>0,5748</a:t>
             </a:r>
             <a:endParaRPr lang="en-US" sz="2800" dirty="0"/>
           </a:p>
@@ -12866,7 +12866,7 @@
                 <a:ea typeface="Calibri" pitchFamily="34" charset="-122"/>
                 <a:cs typeface="Calibri" pitchFamily="34" charset="-120"/>
               </a:rPr>
-              <a:t>F1 SCORE — RandomForest + feat eng</a:t>
+              <a:t>F1 SCORE — MLP umbral 0,63 (PyTorch)</a:t>
             </a:r>
             <a:endParaRPr lang="en-US" sz="1000" dirty="0"/>
           </a:p>
@@ -12964,7 +12964,7 @@
                 <a:ea typeface="Georgia" pitchFamily="34" charset="-122"/>
                 <a:cs typeface="Georgia" pitchFamily="34" charset="-120"/>
               </a:rPr>
-              <a:t>67 %</a:t>
+              <a:t>63 %</a:t>
             </a:r>
             <a:endParaRPr lang="en-US" sz="2800" dirty="0"/>
           </a:p>
@@ -13003,7 +13003,7 @@
                 <a:ea typeface="Calibri" pitchFamily="34" charset="-122"/>
                 <a:cs typeface="Calibri" pitchFamily="34" charset="-120"/>
               </a:rPr>
-              <a:t>RECALL — 1.292 de 1.929 casos</a:t>
+              <a:t>RECALL — 1.210 de 1.929 casos</a:t>
             </a:r>
             <a:endParaRPr lang="en-US" sz="1000" dirty="0"/>
           </a:p>
@@ -14379,7 +14379,7 @@
                 <a:ea typeface="Georgia" pitchFamily="34" charset="-122"/>
                 <a:cs typeface="Georgia" pitchFamily="34" charset="-120"/>
               </a:rPr>
-              <a:t>0,84</a:t>
+              <a:t>0,5748</a:t>
             </a:r>
             <a:endParaRPr lang="en-US" sz="3400" dirty="0"/>
           </a:p>
@@ -14418,7 +14418,7 @@
                 <a:ea typeface="Calibri" pitchFamily="34" charset="-122"/>
                 <a:cs typeface="Calibri" pitchFamily="34" charset="-120"/>
               </a:rPr>
-              <a:t>AUC-ROC</a:t>
+              <a:t>F1 SCORE DEL GANADOR (MLP)</a:t>
             </a:r>
             <a:endParaRPr lang="en-US" sz="900" dirty="0"/>
           </a:p>
@@ -14521,7 +14521,7 @@
                 <a:ea typeface="Calibri" pitchFamily="34" charset="-122"/>
                 <a:cs typeface="Calibri" pitchFamily="34" charset="-120"/>
               </a:rPr>
-              <a:t>Detecta el 67 % de los pacientes con cancer entre los 10.001 de test. Suficiente como filtro inicial de priorizacion clinica.</a:t>
+              <a:t>El MLP en PyTorch supera a los 4 modelos ML clasicos. Detecta el 63 % de los pacientes con cancer entre los 10.001 de test, con 53 % de precision.</a:t>
             </a:r>
             <a:endParaRPr lang="en-US" sz="1100" dirty="0"/>
           </a:p>
@@ -14574,11 +14574,11 @@
             <a:avLst/>
           </a:prstGeom>
           <a:solidFill>
-            <a:srgbClr val="E63946"/>
+            <a:srgbClr val="6A0DAD"/>
           </a:solidFill>
           <a:ln w="12700">
             <a:solidFill>
-              <a:srgbClr val="E63946"/>
+              <a:srgbClr val="6A0DAD"/>
             </a:solidFill>
             <a:prstDash val="solid"/>
           </a:ln>
@@ -14599,11 +14599,11 @@
             <a:avLst/>
           </a:prstGeom>
           <a:solidFill>
-            <a:srgbClr val="E63946"/>
+            <a:srgbClr val="6A0DAD"/>
           </a:solidFill>
           <a:ln w="12700">
             <a:solidFill>
-              <a:srgbClr val="E63946"/>
+              <a:srgbClr val="6A0DAD"/>
             </a:solidFill>
             <a:prstDash val="solid"/>
           </a:ln>
@@ -14642,7 +14642,7 @@
                 <a:ea typeface="Georgia" pitchFamily="34" charset="-122"/>
                 <a:cs typeface="Georgia" pitchFamily="34" charset="-120"/>
               </a:rPr>
-              <a:t>⚙</a:t>
+              <a:t>★</a:t>
             </a:r>
             <a:endParaRPr lang="en-US" sz="2600" dirty="0"/>
           </a:p>
@@ -14675,13 +14675,13 @@
             <a:r>
               <a:rPr lang="en-US" sz="3400" b="1" dirty="0">
                 <a:solidFill>
-                  <a:srgbClr val="E63946"/>
+                  <a:srgbClr val="6A0DAD"/>
                 </a:solidFill>
                 <a:latin typeface="Georgia" pitchFamily="34" charset="0"/>
                 <a:ea typeface="Georgia" pitchFamily="34" charset="-122"/>
                 <a:cs typeface="Georgia" pitchFamily="34" charset="-120"/>
               </a:rPr>
-              <a:t>+0,008</a:t>
+              <a:t>0,84</a:t>
             </a:r>
             <a:endParaRPr lang="en-US" sz="3400" dirty="0"/>
           </a:p>
@@ -14720,7 +14720,7 @@
                 <a:ea typeface="Calibri" pitchFamily="34" charset="-122"/>
                 <a:cs typeface="Calibri" pitchFamily="34" charset="-120"/>
               </a:rPr>
-              <a:t>F1 EN RF · −0,015 EN MLP</a:t>
+              <a:t>AUC-ROC GLOBAL</a:t>
             </a:r>
             <a:endParaRPr lang="en-US" sz="900" dirty="0"/>
           </a:p>
@@ -14784,7 +14784,7 @@
                 <a:ea typeface="Calibri" pitchFamily="34" charset="-122"/>
                 <a:cs typeface="Calibri" pitchFamily="34" charset="-120"/>
               </a:rPr>
-              <a:t>Feature engineering no es universal</a:t>
+              <a:t>La red neuronal supera a los arboles</a:t>
             </a:r>
             <a:endParaRPr lang="en-US" sz="1600" dirty="0"/>
           </a:p>
@@ -14823,7 +14823,7 @@
                 <a:ea typeface="Calibri" pitchFamily="34" charset="-122"/>
                 <a:cs typeface="Calibri" pitchFamily="34" charset="-120"/>
               </a:rPr>
-              <a:t>n_mutaciones y n_comorbilidades ayudan a los arboles pero perjudican al MLP. Hallazgo metodologico defendible.</a:t>
+              <a:t>Tras threshold tuning sobre validacion (umbral=0,63), el MLP queda 1º en F1 por delante de RandomForest (0,5719). Los 5 modelos comparten AUC ≈ 0,84.</a:t>
             </a:r>
             <a:endParaRPr lang="en-US" sz="1100" dirty="0"/>
           </a:p>
@@ -15427,7 +15427,7 @@
                 <a:ea typeface="Calibri" pitchFamily="34" charset="-122"/>
                 <a:cs typeface="Calibri" pitchFamily="34" charset="-120"/>
               </a:rPr>
-              <a:t>Threshold tuning sobre validacion. Test intacto hasta el final. Scaler ajustado solo en train. Seeds fijos en todas las fases.</a:t>
+              <a:t>Threshold tuning sobre validacion. Test intacto hasta el final. Scaler ajustado solo en train. cudnn.deterministic = True en PyTorch.</a:t>
             </a:r>
             <a:endParaRPr lang="en-US" sz="1100" dirty="0"/>
           </a:p>

</xml_diff>